<commit_message>
Update PowerPoint for song #244 in FUBC - Українські
</commit_message>
<xml_diff>
--- a/fubc-ua/244-Я шляхом вузьким йду (Пісні Спасенних №243).pptx
+++ b/fubc-ua/244-Я шляхом вузьким йду (Пісні Спасенних №243).pptx
@@ -1835,7 +1835,7 @@
         </p:nvSpPr>
         <p:spPr>
           <a:xfrm>
-            <a:off x="2703932" y="1962912"/>
+            <a:off x="2802992" y="1962912"/>
             <a:ext cx="0" cy="1386840"/>
           </a:xfrm>
           <a:prstGeom prst="line">
@@ -1858,7 +1858,7 @@
         </p:nvSpPr>
         <p:spPr>
           <a:xfrm>
-            <a:off x="9494164" y="1962912"/>
+            <a:off x="9395104" y="1962912"/>
             <a:ext cx="0" cy="1386840"/>
           </a:xfrm>
           <a:prstGeom prst="line">
@@ -1881,8 +1881,8 @@
         </p:nvSpPr>
         <p:spPr>
           <a:xfrm>
-            <a:off x="9626244" y="2425192"/>
-            <a:ext cx="792480" cy="462280"/>
+            <a:off x="9494164" y="2336292"/>
+            <a:ext cx="1097280" cy="640080"/>
           </a:xfrm>
           <a:prstGeom prst="rect">
             <a:avLst/>
@@ -1898,9 +1898,9 @@
               <a:buNone/>
             </a:pPr>
             <a:r>
-              <a:rPr lang="en-US" sz="2600" b="1" dirty="0">
-                <a:solidFill>
-                  <a:srgbClr val="8A8A8A"/>
+              <a:rPr lang="en-US" sz="3600" b="1" dirty="0">
+                <a:solidFill>
+                  <a:srgbClr val="BBBBBB"/>
                 </a:solidFill>
                 <a:latin typeface="Arial" pitchFamily="34" charset="0"/>
                 <a:ea typeface="Arial" pitchFamily="34" charset="-122"/>
@@ -1908,7 +1908,7 @@
               </a:rPr>
               <a:t>×2</a:t>
             </a:r>
-            <a:endParaRPr lang="en-US" sz="2600" dirty="0"/>
+            <a:endParaRPr lang="en-US" sz="3600" dirty="0"/>
           </a:p>
         </p:txBody>
       </p:sp>
@@ -2176,7 +2176,7 @@
         </p:nvSpPr>
         <p:spPr>
           <a:xfrm>
-            <a:off x="2703932" y="1962912"/>
+            <a:off x="2802992" y="1962912"/>
             <a:ext cx="0" cy="1386840"/>
           </a:xfrm>
           <a:prstGeom prst="line">
@@ -2199,7 +2199,7 @@
         </p:nvSpPr>
         <p:spPr>
           <a:xfrm>
-            <a:off x="9494164" y="1962912"/>
+            <a:off x="9395104" y="1962912"/>
             <a:ext cx="0" cy="1386840"/>
           </a:xfrm>
           <a:prstGeom prst="line">
@@ -2222,8 +2222,8 @@
         </p:nvSpPr>
         <p:spPr>
           <a:xfrm>
-            <a:off x="9626244" y="2425192"/>
-            <a:ext cx="792480" cy="462280"/>
+            <a:off x="9494164" y="2336292"/>
+            <a:ext cx="1097280" cy="640080"/>
           </a:xfrm>
           <a:prstGeom prst="rect">
             <a:avLst/>
@@ -2239,9 +2239,9 @@
               <a:buNone/>
             </a:pPr>
             <a:r>
-              <a:rPr lang="en-US" sz="2600" b="1" dirty="0">
-                <a:solidFill>
-                  <a:srgbClr val="8A8A8A"/>
+              <a:rPr lang="en-US" sz="3600" b="1" dirty="0">
+                <a:solidFill>
+                  <a:srgbClr val="BBBBBB"/>
                 </a:solidFill>
                 <a:latin typeface="Arial" pitchFamily="34" charset="0"/>
                 <a:ea typeface="Arial" pitchFamily="34" charset="-122"/>
@@ -2249,7 +2249,7 @@
               </a:rPr>
               <a:t>×2</a:t>
             </a:r>
-            <a:endParaRPr lang="en-US" sz="2600" dirty="0"/>
+            <a:endParaRPr lang="en-US" sz="3600" dirty="0"/>
           </a:p>
         </p:txBody>
       </p:sp>
@@ -2551,7 +2551,7 @@
         </p:nvSpPr>
         <p:spPr>
           <a:xfrm>
-            <a:off x="2703932" y="1962912"/>
+            <a:off x="2802992" y="1962912"/>
             <a:ext cx="0" cy="1386840"/>
           </a:xfrm>
           <a:prstGeom prst="line">
@@ -2574,7 +2574,7 @@
         </p:nvSpPr>
         <p:spPr>
           <a:xfrm>
-            <a:off x="9494164" y="1962912"/>
+            <a:off x="9395104" y="1962912"/>
             <a:ext cx="0" cy="1386840"/>
           </a:xfrm>
           <a:prstGeom prst="line">
@@ -2597,8 +2597,8 @@
         </p:nvSpPr>
         <p:spPr>
           <a:xfrm>
-            <a:off x="9626244" y="2425192"/>
-            <a:ext cx="792480" cy="462280"/>
+            <a:off x="9494164" y="2336292"/>
+            <a:ext cx="1097280" cy="640080"/>
           </a:xfrm>
           <a:prstGeom prst="rect">
             <a:avLst/>
@@ -2614,9 +2614,9 @@
               <a:buNone/>
             </a:pPr>
             <a:r>
-              <a:rPr lang="en-US" sz="2600" b="1" dirty="0">
-                <a:solidFill>
-                  <a:srgbClr val="8A8A8A"/>
+              <a:rPr lang="en-US" sz="3600" b="1" dirty="0">
+                <a:solidFill>
+                  <a:srgbClr val="BBBBBB"/>
                 </a:solidFill>
                 <a:latin typeface="Arial" pitchFamily="34" charset="0"/>
                 <a:ea typeface="Arial" pitchFamily="34" charset="-122"/>
@@ -2624,7 +2624,7 @@
               </a:rPr>
               <a:t>×2</a:t>
             </a:r>
-            <a:endParaRPr lang="en-US" sz="2600" dirty="0"/>
+            <a:endParaRPr lang="en-US" sz="3600" dirty="0"/>
           </a:p>
         </p:txBody>
       </p:sp>

</xml_diff>